<commit_message>
wikify_simple: restore legacy image/table extraction, persist images with sidecars
- Port legacy fitz-based figure/media extraction into ingest/images.py
- Wire pdf/docx/pptx/html parsers to emit raw images consumed by refresh
- Save images at corpus/images/{doc_id}/{id}.{ext} with .json sidecars
- Add store/corpus.read_doc_images and tests for round-trip

Co-Authored-By: Claude Opus 4.6 (1M context) <noreply@anthropic.com>
</commit_message>
<xml_diff>
--- a/tests/fixtures/tiny/sample.pptx
+++ b/tests/fixtures/tiny/sample.pptx
@@ -3138,6 +3138,30 @@
           </a:p>
         </p:txBody>
       </p:sp>
+      <p:pic>
+        <p:nvPicPr>
+          <p:cNvPr id="4" name="Picture 3" descr="image.png"/>
+          <p:cNvPicPr>
+            <a:picLocks noChangeAspect="1"/>
+          </p:cNvPicPr>
+          <p:nvPr/>
+        </p:nvPicPr>
+        <p:blipFill>
+          <a:blip r:embed="rId2"/>
+          <a:stretch>
+            <a:fillRect/>
+          </a:stretch>
+        </p:blipFill>
+        <p:spPr>
+          <a:xfrm>
+            <a:off x="3657600" y="3657600"/>
+            <a:ext cx="1828800" cy="1828800"/>
+          </a:xfrm>
+          <a:prstGeom prst="rect">
+            <a:avLst/>
+          </a:prstGeom>
+        </p:spPr>
+      </p:pic>
     </p:spTree>
   </p:cSld>
   <p:clrMapOvr>

</xml_diff>